<commit_message>
Sync from Hafiz's main, 2026-10-22
The working code as of 22 October 2026: the friendlier workspace (the loop as a path of stops across every step, each helper asking its step's question in a bubble, outlines and lips on every control), the film rendered on it, and a README cut to what you need to run, check and branch. The plan and the run records stay in Hafiz's repo.

Lyceum-Sync: 2026-10-22T05:53:28.766Z
</commit_message>
<xml_diff>
--- a/docs/presentation/sample-CS310-week-6-teaching-pack.pptx
+++ b/docs/presentation/sample-CS310-week-6-teaching-pack.pptx
@@ -1302,7 +1302,7 @@
     <p:bg>
       <p:bgPr>
         <a:solidFill>
-          <a:srgbClr val="14213D"/>
+          <a:srgbClr val="0F2A20"/>
         </a:solidFill>
       </p:bgPr>
     </p:bg>
@@ -1349,11 +1349,11 @@
             <a:r>
               <a:rPr lang="en-US" sz="3400" b="1" dirty="0">
                 <a:solidFill>
-                  <a:srgbClr val="FBFBF8"/>
+                  <a:srgbClr val="FFFFFF"/>
                 </a:solidFill>
-                <a:latin typeface="Georgia" pitchFamily="34" charset="0"/>
-                <a:ea typeface="Georgia" pitchFamily="34" charset="-122"/>
-                <a:cs typeface="Georgia" pitchFamily="34" charset="-120"/>
+                <a:latin typeface="Calibri" pitchFamily="34" charset="0"/>
+                <a:ea typeface="Calibri" pitchFamily="34" charset="-122"/>
+                <a:cs typeface="Calibri" pitchFamily="34" charset="-120"/>
               </a:rPr>
               <a:t>CS310 week 6: Dashboard lab: from a messy dataset to a decision</a:t>
             </a:r>
@@ -1390,7 +1390,7 @@
             <a:r>
               <a:rPr lang="en-US" sz="2000" dirty="0">
                 <a:solidFill>
-                  <a:srgbClr val="BFD8D5"/>
+                  <a:srgbClr val="B9CDBF"/>
                 </a:solidFill>
                 <a:latin typeface="Calibri" pitchFamily="34" charset="0"/>
                 <a:ea typeface="Calibri" pitchFamily="34" charset="-122"/>
@@ -1431,13 +1431,13 @@
             <a:r>
               <a:rPr lang="en-US" sz="1400" dirty="0">
                 <a:solidFill>
-                  <a:srgbClr val="BFD8D5"/>
+                  <a:srgbClr val="B9CDBF"/>
                 </a:solidFill>
                 <a:latin typeface="Calibri" pitchFamily="34" charset="0"/>
                 <a:ea typeface="Calibri" pitchFamily="34" charset="-122"/>
                 <a:cs typeface="Calibri" pitchFamily="34" charset="-120"/>
               </a:rPr>
-              <a:t>Prepared by Dr Sobri on 2026-10-08T23:57:19.297Z.</a:t>
+              <a:t>Prepared by Dr Sobri on 2026-10-22T10:00:00Z.</a:t>
             </a:r>
             <a:endParaRPr lang="en-US" sz="1400" dirty="0"/>
           </a:p>
@@ -1448,7 +1448,7 @@
             <a:r>
               <a:rPr lang="en-US" sz="1400" dirty="0">
                 <a:solidFill>
-                  <a:srgbClr val="BFD8D5"/>
+                  <a:srgbClr val="B9CDBF"/>
                 </a:solidFill>
                 <a:latin typeface="Calibri" pitchFamily="34" charset="0"/>
                 <a:ea typeface="Calibri" pitchFamily="34" charset="-122"/>
@@ -1487,7 +1487,7 @@
             <a:r>
               <a:rPr lang="en-US" sz="1000" dirty="0">
                 <a:solidFill>
-                  <a:srgbClr val="9AD4A8"/>
+                  <a:srgbClr val="B9CDBF"/>
                 </a:solidFill>
                 <a:latin typeface="Calibri" pitchFamily="34" charset="0"/>
                 <a:ea typeface="Calibri" pitchFamily="34" charset="-122"/>
@@ -1513,7 +1513,7 @@
     <p:bg>
       <p:bgPr>
         <a:solidFill>
-          <a:srgbClr val="FBFBF8"/>
+          <a:srgbClr val="FFFFFF"/>
         </a:solidFill>
       </p:bgPr>
     </p:bg>
@@ -1560,11 +1560,11 @@
             <a:r>
               <a:rPr lang="en-US" sz="2600" b="1" dirty="0">
                 <a:solidFill>
-                  <a:srgbClr val="14213D"/>
+                  <a:srgbClr val="0F2A20"/>
                 </a:solidFill>
-                <a:latin typeface="Georgia" pitchFamily="34" charset="0"/>
-                <a:ea typeface="Georgia" pitchFamily="34" charset="-122"/>
-                <a:cs typeface="Georgia" pitchFamily="34" charset="-120"/>
+                <a:latin typeface="Calibri" pitchFamily="34" charset="0"/>
+                <a:ea typeface="Calibri" pitchFamily="34" charset="-122"/>
+                <a:cs typeface="Calibri" pitchFamily="34" charset="-120"/>
               </a:rPr>
               <a:t>Learning outcomes for this session</a:t>
             </a:r>
@@ -1605,13 +1605,13 @@
             <a:r>
               <a:rPr lang="en-US" sz="1400" dirty="0">
                 <a:solidFill>
-                  <a:srgbClr val="1F2937"/>
+                  <a:srgbClr val="0F2A20"/>
                 </a:solidFill>
                 <a:latin typeface="Calibri" pitchFamily="34" charset="0"/>
                 <a:ea typeface="Calibri" pitchFamily="34" charset="-122"/>
                 <a:cs typeface="Calibri" pitchFamily="34" charset="-120"/>
               </a:rPr>
-              <a:t>CLO5: Data visualisation</a:t>
+              <a:t>CLO5: Data visualisation with dashboards that answer a stakeholder's question</a:t>
             </a:r>
             <a:endParaRPr lang="en-US" sz="1400" dirty="0"/>
           </a:p>
@@ -1644,7 +1644,7 @@
             <a:r>
               <a:rPr lang="en-US" sz="900" dirty="0">
                 <a:solidFill>
-                  <a:srgbClr val="6A7179"/>
+                  <a:srgbClr val="4E6258"/>
                 </a:solidFill>
                 <a:latin typeface="Calibri" pitchFamily="34" charset="0"/>
                 <a:ea typeface="Calibri" pitchFamily="34" charset="-122"/>
@@ -1670,7 +1670,7 @@
     <p:bg>
       <p:bgPr>
         <a:solidFill>
-          <a:srgbClr val="FBFBF8"/>
+          <a:srgbClr val="FFFFFF"/>
         </a:solidFill>
       </p:bgPr>
     </p:bg>
@@ -1717,11 +1717,11 @@
             <a:r>
               <a:rPr lang="en-US" sz="2600" b="1" dirty="0">
                 <a:solidFill>
-                  <a:srgbClr val="14213D"/>
+                  <a:srgbClr val="0F2A20"/>
                 </a:solidFill>
-                <a:latin typeface="Georgia" pitchFamily="34" charset="0"/>
-                <a:ea typeface="Georgia" pitchFamily="34" charset="-122"/>
-                <a:cs typeface="Georgia" pitchFamily="34" charset="-120"/>
+                <a:latin typeface="Calibri" pitchFamily="34" charset="0"/>
+                <a:ea typeface="Calibri" pitchFamily="34" charset="-122"/>
+                <a:cs typeface="Calibri" pitchFamily="34" charset="-120"/>
               </a:rPr>
               <a:t>Why this matters: what employers ask for</a:t>
             </a:r>
@@ -1762,13 +1762,13 @@
             <a:r>
               <a:rPr lang="en-US" sz="1400" dirty="0">
                 <a:solidFill>
-                  <a:srgbClr val="1F2937"/>
+                  <a:srgbClr val="0F2A20"/>
                 </a:solidFill>
                 <a:latin typeface="Calibri" pitchFamily="34" charset="0"/>
                 <a:ea typeface="Calibri" pitchFamily="34" charset="-122"/>
                 <a:cs typeface="Calibri" pitchFamily="34" charset="-120"/>
               </a:rPr>
-              <a:t>dashboards: 4 of 5 reviewed postings (37.6% to 96.4%). Coverage today: Introduced; target: Practised.</a:t>
+              <a:t>dashboards: 5 of 9 reviewed postings (26.7% to 81.1%). Coverage today: Introduced; target: Practised.</a:t>
             </a:r>
             <a:endParaRPr lang="en-US" sz="1400" dirty="0"/>
           </a:p>
@@ -1782,7 +1782,7 @@
             <a:r>
               <a:rPr lang="en-US" sz="1400" dirty="0">
                 <a:solidFill>
-                  <a:srgbClr val="6A7179"/>
+                  <a:srgbClr val="4E6258"/>
                 </a:solidFill>
                 <a:latin typeface="Calibri" pitchFamily="34" charset="0"/>
                 <a:ea typeface="Calibri" pitchFamily="34" charset="-122"/>
@@ -1821,7 +1821,7 @@
             <a:r>
               <a:rPr lang="en-US" sz="900" dirty="0">
                 <a:solidFill>
-                  <a:srgbClr val="6A7179"/>
+                  <a:srgbClr val="4E6258"/>
                 </a:solidFill>
                 <a:latin typeface="Calibri" pitchFamily="34" charset="0"/>
                 <a:ea typeface="Calibri" pitchFamily="34" charset="-122"/>
@@ -1847,7 +1847,7 @@
     <p:bg>
       <p:bgPr>
         <a:solidFill>
-          <a:srgbClr val="FBFBF8"/>
+          <a:srgbClr val="FFFFFF"/>
         </a:solidFill>
       </p:bgPr>
     </p:bg>
@@ -1894,11 +1894,11 @@
             <a:r>
               <a:rPr lang="en-US" sz="2600" b="1" dirty="0">
                 <a:solidFill>
-                  <a:srgbClr val="14213D"/>
+                  <a:srgbClr val="0F2A20"/>
                 </a:solidFill>
-                <a:latin typeface="Georgia" pitchFamily="34" charset="0"/>
-                <a:ea typeface="Georgia" pitchFamily="34" charset="-122"/>
-                <a:cs typeface="Georgia" pitchFamily="34" charset="-120"/>
+                <a:latin typeface="Calibri" pitchFamily="34" charset="0"/>
+                <a:ea typeface="Calibri" pitchFamily="34" charset="-122"/>
+                <a:cs typeface="Calibri" pitchFamily="34" charset="-120"/>
               </a:rPr>
               <a:t>Learning activity</a:t>
             </a:r>
@@ -1935,7 +1935,7 @@
             <a:r>
               <a:rPr lang="en-US" sz="1600" dirty="0">
                 <a:solidFill>
-                  <a:srgbClr val="1F2937"/>
+                  <a:srgbClr val="0F2A20"/>
                 </a:solidFill>
                 <a:latin typeface="Calibri" pitchFamily="34" charset="0"/>
                 <a:ea typeface="Calibri" pitchFamily="34" charset="-122"/>
@@ -1974,7 +1974,7 @@
             <a:r>
               <a:rPr lang="en-US" sz="900" dirty="0">
                 <a:solidFill>
-                  <a:srgbClr val="6A7179"/>
+                  <a:srgbClr val="4E6258"/>
                 </a:solidFill>
                 <a:latin typeface="Calibri" pitchFamily="34" charset="0"/>
                 <a:ea typeface="Calibri" pitchFamily="34" charset="-122"/>
@@ -2000,7 +2000,7 @@
     <p:bg>
       <p:bgPr>
         <a:solidFill>
-          <a:srgbClr val="FBFBF8"/>
+          <a:srgbClr val="FFFFFF"/>
         </a:solidFill>
       </p:bgPr>
     </p:bg>
@@ -2047,11 +2047,11 @@
             <a:r>
               <a:rPr lang="en-US" sz="2600" b="1" dirty="0">
                 <a:solidFill>
-                  <a:srgbClr val="14213D"/>
+                  <a:srgbClr val="0F2A20"/>
                 </a:solidFill>
-                <a:latin typeface="Georgia" pitchFamily="34" charset="0"/>
-                <a:ea typeface="Georgia" pitchFamily="34" charset="-122"/>
-                <a:cs typeface="Georgia" pitchFamily="34" charset="-120"/>
+                <a:latin typeface="Calibri" pitchFamily="34" charset="0"/>
+                <a:ea typeface="Calibri" pitchFamily="34" charset="-122"/>
+                <a:cs typeface="Calibri" pitchFamily="34" charset="-120"/>
               </a:rPr>
               <a:t>Check for understanding</a:t>
             </a:r>
@@ -2088,7 +2088,7 @@
             <a:r>
               <a:rPr lang="en-US" sz="1600" dirty="0">
                 <a:solidFill>
-                  <a:srgbClr val="1F2937"/>
+                  <a:srgbClr val="0F2A20"/>
                 </a:solidFill>
                 <a:latin typeface="Calibri" pitchFamily="34" charset="0"/>
                 <a:ea typeface="Calibri" pitchFamily="34" charset="-122"/>
@@ -2127,7 +2127,7 @@
             <a:r>
               <a:rPr lang="en-US" sz="900" dirty="0">
                 <a:solidFill>
-                  <a:srgbClr val="6A7179"/>
+                  <a:srgbClr val="4E6258"/>
                 </a:solidFill>
                 <a:latin typeface="Calibri" pitchFamily="34" charset="0"/>
                 <a:ea typeface="Calibri" pitchFamily="34" charset="-122"/>
@@ -2153,7 +2153,7 @@
     <p:bg>
       <p:bgPr>
         <a:solidFill>
-          <a:srgbClr val="FBFBF8"/>
+          <a:srgbClr val="FFFFFF"/>
         </a:solidFill>
       </p:bgPr>
     </p:bg>
@@ -2200,11 +2200,11 @@
             <a:r>
               <a:rPr lang="en-US" sz="2600" b="1" dirty="0">
                 <a:solidFill>
-                  <a:srgbClr val="14213D"/>
+                  <a:srgbClr val="0F2A20"/>
                 </a:solidFill>
-                <a:latin typeface="Georgia" pitchFamily="34" charset="0"/>
-                <a:ea typeface="Georgia" pitchFamily="34" charset="-122"/>
-                <a:cs typeface="Georgia" pitchFamily="34" charset="-120"/>
+                <a:latin typeface="Calibri" pitchFamily="34" charset="0"/>
+                <a:ea typeface="Calibri" pitchFamily="34" charset="-122"/>
+                <a:cs typeface="Calibri" pitchFamily="34" charset="-120"/>
               </a:rPr>
               <a:t>Resources and references</a:t>
             </a:r>
@@ -2241,13 +2241,13 @@
             <a:r>
               <a:rPr lang="en-US" sz="1600" dirty="0">
                 <a:solidFill>
-                  <a:srgbClr val="1F2937"/>
+                  <a:srgbClr val="0F2A20"/>
                 </a:solidFill>
                 <a:latin typeface="Calibri" pitchFamily="34" charset="0"/>
                 <a:ea typeface="Calibri" pitchFamily="34" charset="-122"/>
                 <a:cs typeface="Calibri" pitchFamily="34" charset="-120"/>
               </a:rPr>
-              <a:t>Course notes chapter 6; the postings quoted in this pack.</a:t>
+              <a:t>No resources recorded.</a:t>
             </a:r>
             <a:endParaRPr lang="en-US" sz="1600" dirty="0"/>
           </a:p>
@@ -2280,7 +2280,7 @@
             <a:r>
               <a:rPr lang="en-US" sz="900" dirty="0">
                 <a:solidFill>
-                  <a:srgbClr val="6A7179"/>
+                  <a:srgbClr val="4E6258"/>
                 </a:solidFill>
                 <a:latin typeface="Calibri" pitchFamily="34" charset="0"/>
                 <a:ea typeface="Calibri" pitchFamily="34" charset="-122"/>

</xml_diff>